<commit_message>
cleanup slides and remove excess text
</commit_message>
<xml_diff>
--- a/slides-pptx/08c-sql-joins.pptx
+++ b/slides-pptx/08c-sql-joins.pptx
@@ -270,7 +270,7 @@
       <p15:sldGuideLst xmlns:p15="http://schemas.microsoft.com/office/powerpoint/2012/main"/>
     </p:ext>
     <p:ext uri="GoogleSlidesCustomDataVersion2">
-      <go:slidesCustomData xmlns:go="http://customooxmlschemas.google.com/" xmlns:ahyp="http://schemas.microsoft.com/office/drawing/2018/hyperlinkcolor" xmlns:p15="http://schemas.microsoft.com/office/powerpoint/2012/main" xmlns:p14="http://schemas.microsoft.com/office/powerpoint/2010/main" xmlns:com="http://schemas.openxmlformats.org/drawingml/2006/compatibility" xmlns:pvml="urn:schemas-microsoft-com:office:powerpoint" xmlns:v="urn:schemas-microsoft-com:vml" xmlns:o="urn:schemas-microsoft-com:office:office" xmlns:dgm="http://schemas.openxmlformats.org/drawingml/2006/diagram" xmlns:c="http://schemas.openxmlformats.org/drawingml/2006/chart" xmlns:mv="urn:schemas-microsoft-com:mac:vml" xmlns:mc="http://schemas.openxmlformats.org/markup-compatibility/2006" xmlns="" r:id="rId39" roundtripDataSignature="AMtx7mhfDKrfYraVQTmOsaZXXQS4aGPdYw=="/>
+      <go:slidesCustomData xmlns="" xmlns:mc="http://schemas.openxmlformats.org/markup-compatibility/2006" xmlns:mv="urn:schemas-microsoft-com:mac:vml" xmlns:c="http://schemas.openxmlformats.org/drawingml/2006/chart" xmlns:dgm="http://schemas.openxmlformats.org/drawingml/2006/diagram" xmlns:o="urn:schemas-microsoft-com:office:office" xmlns:v="urn:schemas-microsoft-com:vml" xmlns:pvml="urn:schemas-microsoft-com:office:powerpoint" xmlns:com="http://schemas.openxmlformats.org/drawingml/2006/compatibility" xmlns:p14="http://schemas.microsoft.com/office/powerpoint/2010/main" xmlns:p15="http://schemas.microsoft.com/office/powerpoint/2012/main" xmlns:ahyp="http://schemas.microsoft.com/office/drawing/2018/hyperlinkcolor" xmlns:go="http://customooxmlschemas.google.com/" r:id="rId39" roundtripDataSignature="AMtx7mhfDKrfYraVQTmOsaZXXQS4aGPdYw=="/>
     </p:ext>
   </p:extLst>
 </p:presentation>
@@ -13744,7 +13744,7 @@
 </file>
 
 <file path=ppt/slides/slide11.xml><?xml version="1.0" encoding="utf-8"?>
-<p:sld xmlns:a="http://schemas.openxmlformats.org/drawingml/2006/main" xmlns:r="http://schemas.openxmlformats.org/officeDocument/2006/relationships" xmlns:p="http://schemas.openxmlformats.org/presentationml/2006/main">
+<p:sld xmlns:a="http://schemas.openxmlformats.org/drawingml/2006/main" xmlns:r="http://schemas.openxmlformats.org/officeDocument/2006/relationships" xmlns:p="http://schemas.openxmlformats.org/presentationml/2006/main" show="0">
   <p:cSld>
     <p:spTree>
       <p:nvGrpSpPr>
@@ -15163,7 +15163,7 @@
 </file>
 
 <file path=ppt/slides/slide12.xml><?xml version="1.0" encoding="utf-8"?>
-<p:sld xmlns:a="http://schemas.openxmlformats.org/drawingml/2006/main" xmlns:r="http://schemas.openxmlformats.org/officeDocument/2006/relationships" xmlns:p="http://schemas.openxmlformats.org/presentationml/2006/main">
+<p:sld xmlns:a="http://schemas.openxmlformats.org/drawingml/2006/main" xmlns:r="http://schemas.openxmlformats.org/officeDocument/2006/relationships" xmlns:p="http://schemas.openxmlformats.org/presentationml/2006/main" show="0">
   <p:cSld>
     <p:bg>
       <p:bgPr>

</xml_diff>